<commit_message>
Fix UI sizing and layout, simplify problems text, remove footer and question slide (n)
</commit_message>
<xml_diff>
--- a/bank-normal/bank_normal_presentation.pptx
+++ b/bank-normal/bank_normal_presentation.pptx
@@ -33,7 +33,6 @@
     <p:sldId id="281" r:id="rId32"/>
     <p:sldId id="282" r:id="rId33"/>
     <p:sldId id="283" r:id="rId34"/>
-    <p:sldId id="284" r:id="rId35"/>
   </p:sldIdLst>
   <p:sldSz cx="12191695" cy="6858000" type="screen4x3"/>
   <p:notesSz cx="6858000" cy="9144000"/>
@@ -3317,8 +3316,8 @@
         </p:nvSpPr>
         <p:spPr>
           <a:xfrm>
-            <a:off x="457200" y="6492240"/>
-            <a:ext cx="4572000" cy="274320"/>
+            <a:off x="457200" y="548640"/>
+            <a:ext cx="10972800" cy="914400"/>
           </a:xfrm>
           <a:prstGeom prst="rect">
             <a:avLst/>
@@ -3332,7 +3331,7 @@
           <a:lstStyle/>
           <a:p>
             <a:pPr>
-              <a:defRPr sz="1200">
+              <a:defRPr sz="2400">
                 <a:solidFill>
                   <a:srgbClr val="757575"/>
                 </a:solidFill>
@@ -3340,7 +3339,7 @@
               </a:defRPr>
             </a:pPr>
             <a:r>
-              <a:t>銀行業界の基礎知識 - 易化版</a:t>
+              <a:t>魔法の仕組み：信用創造</a:t>
             </a:r>
           </a:p>
         </p:txBody>
@@ -3348,42 +3347,6 @@
       <p:sp>
         <p:nvSpPr>
           <p:cNvPr id="5" name="TextBox 4"/>
-          <p:cNvSpPr txBox="1"/>
-          <p:nvPr/>
-        </p:nvSpPr>
-        <p:spPr>
-          <a:xfrm>
-            <a:off x="457200" y="548640"/>
-            <a:ext cx="10972800" cy="914400"/>
-          </a:xfrm>
-          <a:prstGeom prst="rect">
-            <a:avLst/>
-          </a:prstGeom>
-          <a:noFill/>
-        </p:spPr>
-        <p:txBody>
-          <a:bodyPr wrap="none">
-            <a:spAutoFit/>
-          </a:bodyPr>
-          <a:lstStyle/>
-          <a:p>
-            <a:pPr>
-              <a:defRPr sz="2400">
-                <a:solidFill>
-                  <a:srgbClr val="757575"/>
-                </a:solidFill>
-                <a:latin typeface="Hiragino Sans"/>
-              </a:defRPr>
-            </a:pPr>
-            <a:r>
-              <a:t>魔法の仕組み：信用創造</a:t>
-            </a:r>
-          </a:p>
-        </p:txBody>
-      </p:sp>
-      <p:sp>
-        <p:nvSpPr>
-          <p:cNvPr id="6" name="TextBox 5"/>
           <p:cNvSpPr txBox="1"/>
           <p:nvPr/>
         </p:nvSpPr>
@@ -3419,7 +3382,7 @@
       </p:sp>
       <p:sp>
         <p:nvSpPr>
-          <p:cNvPr id="7" name="Oval 6"/>
+          <p:cNvPr id="6" name="Oval 5"/>
           <p:cNvSpPr/>
           <p:nvPr/>
         </p:nvSpPr>
@@ -3477,7 +3440,7 @@
       </p:sp>
       <p:sp>
         <p:nvSpPr>
-          <p:cNvPr id="8" name="Right Arrow 7"/>
+          <p:cNvPr id="7" name="Right Arrow 6"/>
           <p:cNvSpPr/>
           <p:nvPr/>
         </p:nvSpPr>
@@ -3515,7 +3478,7 @@
       </p:sp>
       <p:sp>
         <p:nvSpPr>
-          <p:cNvPr id="9" name="Oval 8"/>
+          <p:cNvPr id="8" name="Oval 7"/>
           <p:cNvSpPr/>
           <p:nvPr/>
         </p:nvSpPr>
@@ -3573,7 +3536,7 @@
       </p:sp>
       <p:sp>
         <p:nvSpPr>
-          <p:cNvPr id="10" name="Right Arrow 9"/>
+          <p:cNvPr id="9" name="Right Arrow 8"/>
           <p:cNvSpPr/>
           <p:nvPr/>
         </p:nvSpPr>
@@ -3611,7 +3574,7 @@
       </p:sp>
       <p:sp>
         <p:nvSpPr>
-          <p:cNvPr id="11" name="Oval 10"/>
+          <p:cNvPr id="10" name="Oval 9"/>
           <p:cNvSpPr/>
           <p:nvPr/>
         </p:nvSpPr>
@@ -3669,7 +3632,7 @@
       </p:sp>
       <p:sp>
         <p:nvSpPr>
-          <p:cNvPr id="12" name="Right Arrow 11"/>
+          <p:cNvPr id="11" name="Right Arrow 10"/>
           <p:cNvSpPr/>
           <p:nvPr/>
         </p:nvSpPr>
@@ -3707,7 +3670,7 @@
       </p:sp>
       <p:sp>
         <p:nvSpPr>
-          <p:cNvPr id="13" name="Oval 12"/>
+          <p:cNvPr id="12" name="Oval 11"/>
           <p:cNvSpPr/>
           <p:nvPr/>
         </p:nvSpPr>
@@ -3760,7 +3723,7 @@
       </p:sp>
       <p:sp>
         <p:nvSpPr>
-          <p:cNvPr id="14" name="TextBox 13"/>
+          <p:cNvPr id="13" name="TextBox 12"/>
           <p:cNvSpPr txBox="1"/>
           <p:nvPr/>
         </p:nvSpPr>
@@ -3895,8 +3858,8 @@
         </p:nvSpPr>
         <p:spPr>
           <a:xfrm>
-            <a:off x="457200" y="6492240"/>
-            <a:ext cx="4572000" cy="274320"/>
+            <a:off x="457200" y="548640"/>
+            <a:ext cx="10972800" cy="914400"/>
           </a:xfrm>
           <a:prstGeom prst="rect">
             <a:avLst/>
@@ -3910,7 +3873,7 @@
           <a:lstStyle/>
           <a:p>
             <a:pPr>
-              <a:defRPr sz="1200">
+              <a:defRPr sz="2400">
                 <a:solidFill>
                   <a:srgbClr val="757575"/>
                 </a:solidFill>
@@ -3918,7 +3881,7 @@
               </a:defRPr>
             </a:pPr>
             <a:r>
-              <a:t>銀行業界の基礎知識 - 易化版</a:t>
+              <a:t>信用創造のタネあかし</a:t>
             </a:r>
           </a:p>
         </p:txBody>
@@ -3926,42 +3889,6 @@
       <p:sp>
         <p:nvSpPr>
           <p:cNvPr id="5" name="TextBox 4"/>
-          <p:cNvSpPr txBox="1"/>
-          <p:nvPr/>
-        </p:nvSpPr>
-        <p:spPr>
-          <a:xfrm>
-            <a:off x="457200" y="548640"/>
-            <a:ext cx="10972800" cy="914400"/>
-          </a:xfrm>
-          <a:prstGeom prst="rect">
-            <a:avLst/>
-          </a:prstGeom>
-          <a:noFill/>
-        </p:spPr>
-        <p:txBody>
-          <a:bodyPr wrap="none">
-            <a:spAutoFit/>
-          </a:bodyPr>
-          <a:lstStyle/>
-          <a:p>
-            <a:pPr>
-              <a:defRPr sz="2400">
-                <a:solidFill>
-                  <a:srgbClr val="757575"/>
-                </a:solidFill>
-                <a:latin typeface="Hiragino Sans"/>
-              </a:defRPr>
-            </a:pPr>
-            <a:r>
-              <a:t>信用創造のタネあかし</a:t>
-            </a:r>
-          </a:p>
-        </p:txBody>
-      </p:sp>
-      <p:sp>
-        <p:nvSpPr>
-          <p:cNvPr id="6" name="TextBox 5"/>
           <p:cNvSpPr txBox="1"/>
           <p:nvPr/>
         </p:nvSpPr>
@@ -3997,14 +3924,14 @@
       </p:sp>
       <p:sp>
         <p:nvSpPr>
-          <p:cNvPr id="7" name="TextBox 6"/>
+          <p:cNvPr id="6" name="TextBox 5"/>
           <p:cNvSpPr txBox="1"/>
           <p:nvPr/>
         </p:nvSpPr>
         <p:spPr>
           <a:xfrm>
-            <a:off x="457200" y="2743200"/>
-            <a:ext cx="11277295" cy="3474720"/>
+            <a:off x="365760" y="2743200"/>
+            <a:ext cx="11430000" cy="3474720"/>
           </a:xfrm>
           <a:prstGeom prst="rect">
             <a:avLst/>
@@ -4173,8 +4100,8 @@
         </p:nvSpPr>
         <p:spPr>
           <a:xfrm>
-            <a:off x="457200" y="6492240"/>
-            <a:ext cx="4572000" cy="274320"/>
+            <a:off x="457200" y="548640"/>
+            <a:ext cx="10972800" cy="914400"/>
           </a:xfrm>
           <a:prstGeom prst="rect">
             <a:avLst/>
@@ -4188,7 +4115,7 @@
           <a:lstStyle/>
           <a:p>
             <a:pPr>
-              <a:defRPr sz="1200">
+              <a:defRPr sz="2400">
                 <a:solidFill>
                   <a:srgbClr val="757575"/>
                 </a:solidFill>
@@ -4196,7 +4123,7 @@
               </a:defRPr>
             </a:pPr>
             <a:r>
-              <a:t>銀行業界の基礎知識 - 易化版</a:t>
+              <a:t>どうやって儲ける？ (利ざや)</a:t>
             </a:r>
           </a:p>
         </p:txBody>
@@ -4204,42 +4131,6 @@
       <p:sp>
         <p:nvSpPr>
           <p:cNvPr id="5" name="TextBox 4"/>
-          <p:cNvSpPr txBox="1"/>
-          <p:nvPr/>
-        </p:nvSpPr>
-        <p:spPr>
-          <a:xfrm>
-            <a:off x="457200" y="548640"/>
-            <a:ext cx="10972800" cy="914400"/>
-          </a:xfrm>
-          <a:prstGeom prst="rect">
-            <a:avLst/>
-          </a:prstGeom>
-          <a:noFill/>
-        </p:spPr>
-        <p:txBody>
-          <a:bodyPr wrap="none">
-            <a:spAutoFit/>
-          </a:bodyPr>
-          <a:lstStyle/>
-          <a:p>
-            <a:pPr>
-              <a:defRPr sz="2400">
-                <a:solidFill>
-                  <a:srgbClr val="757575"/>
-                </a:solidFill>
-                <a:latin typeface="Hiragino Sans"/>
-              </a:defRPr>
-            </a:pPr>
-            <a:r>
-              <a:t>どうやって儲ける？ (利ざや)</a:t>
-            </a:r>
-          </a:p>
-        </p:txBody>
-      </p:sp>
-      <p:sp>
-        <p:nvSpPr>
-          <p:cNvPr id="6" name="TextBox 5"/>
           <p:cNvSpPr txBox="1"/>
           <p:nvPr/>
         </p:nvSpPr>
@@ -4275,14 +4166,14 @@
       </p:sp>
       <p:sp>
         <p:nvSpPr>
-          <p:cNvPr id="7" name="Rounded Rectangle 6"/>
+          <p:cNvPr id="6" name="Rounded Rectangle 5"/>
           <p:cNvSpPr/>
           <p:nvPr/>
         </p:nvSpPr>
         <p:spPr>
           <a:xfrm>
-            <a:off x="1828800" y="3200400"/>
-            <a:ext cx="2743200" cy="1828800"/>
+            <a:off x="914400" y="3200400"/>
+            <a:ext cx="3017520" cy="2103120"/>
           </a:xfrm>
           <a:prstGeom prst="roundRect">
             <a:avLst/>
@@ -4315,7 +4206,7 @@
           <a:lstStyle/>
           <a:p>
             <a:pPr algn="ctr">
-              <a:defRPr sz="2000" b="1">
+              <a:defRPr sz="2200" b="1">
                 <a:solidFill>
                   <a:srgbClr val="1C1B19"/>
                 </a:solidFill>
@@ -4333,14 +4224,14 @@
       </p:sp>
       <p:sp>
         <p:nvSpPr>
-          <p:cNvPr id="8" name="Rounded Rectangle 7"/>
+          <p:cNvPr id="7" name="Rounded Rectangle 6"/>
           <p:cNvSpPr/>
           <p:nvPr/>
         </p:nvSpPr>
         <p:spPr>
           <a:xfrm>
-            <a:off x="5029200" y="3200400"/>
-            <a:ext cx="2743200" cy="1828800"/>
+            <a:off x="4389120" y="3200400"/>
+            <a:ext cx="3017520" cy="2103120"/>
           </a:xfrm>
           <a:prstGeom prst="roundRect">
             <a:avLst/>
@@ -4368,7 +4259,7 @@
           <a:lstStyle/>
           <a:p>
             <a:pPr algn="ctr">
-              <a:defRPr sz="2000" b="1">
+              <a:defRPr sz="2200" b="1">
                 <a:solidFill>
                   <a:srgbClr val="FFFFFF"/>
                 </a:solidFill>
@@ -4386,14 +4277,14 @@
       </p:sp>
       <p:sp>
         <p:nvSpPr>
-          <p:cNvPr id="9" name="Rounded Rectangle 8"/>
+          <p:cNvPr id="8" name="Rounded Rectangle 7"/>
           <p:cNvSpPr/>
           <p:nvPr/>
         </p:nvSpPr>
         <p:spPr>
           <a:xfrm>
-            <a:off x="8229600" y="3200400"/>
-            <a:ext cx="2743200" cy="1828800"/>
+            <a:off x="7863840" y="3200400"/>
+            <a:ext cx="3200400" cy="2103120"/>
           </a:xfrm>
           <a:prstGeom prst="roundRect">
             <a:avLst/>
@@ -4421,7 +4312,7 @@
           <a:lstStyle/>
           <a:p>
             <a:pPr algn="ctr">
-              <a:defRPr sz="2400" b="1">
+              <a:defRPr sz="2600" b="1">
                 <a:solidFill>
                   <a:srgbClr val="FFFFFF"/>
                 </a:solidFill>
@@ -4439,14 +4330,14 @@
       </p:sp>
       <p:sp>
         <p:nvSpPr>
-          <p:cNvPr id="10" name="TextBox 9"/>
+          <p:cNvPr id="9" name="TextBox 8"/>
           <p:cNvSpPr txBox="1"/>
           <p:nvPr/>
         </p:nvSpPr>
         <p:spPr>
           <a:xfrm>
-            <a:off x="1828800" y="5303520"/>
-            <a:ext cx="9144000" cy="914400"/>
+            <a:off x="914400" y="5486400"/>
+            <a:ext cx="10362895" cy="914400"/>
           </a:xfrm>
           <a:prstGeom prst="rect">
             <a:avLst/>
@@ -4574,8 +4465,8 @@
         </p:nvSpPr>
         <p:spPr>
           <a:xfrm>
-            <a:off x="457200" y="6492240"/>
-            <a:ext cx="4572000" cy="274320"/>
+            <a:off x="457200" y="548640"/>
+            <a:ext cx="10972800" cy="914400"/>
           </a:xfrm>
           <a:prstGeom prst="rect">
             <a:avLst/>
@@ -4589,7 +4480,7 @@
           <a:lstStyle/>
           <a:p>
             <a:pPr>
-              <a:defRPr sz="1200">
+              <a:defRPr sz="2400">
                 <a:solidFill>
                   <a:srgbClr val="757575"/>
                 </a:solidFill>
@@ -4597,7 +4488,7 @@
               </a:defRPr>
             </a:pPr>
             <a:r>
-              <a:t>銀行業界の基礎知識 - 易化版</a:t>
+              <a:t>他の儲け方 (手数料ビジネス)</a:t>
             </a:r>
           </a:p>
         </p:txBody>
@@ -4605,42 +4496,6 @@
       <p:sp>
         <p:nvSpPr>
           <p:cNvPr id="5" name="TextBox 4"/>
-          <p:cNvSpPr txBox="1"/>
-          <p:nvPr/>
-        </p:nvSpPr>
-        <p:spPr>
-          <a:xfrm>
-            <a:off x="457200" y="548640"/>
-            <a:ext cx="10972800" cy="914400"/>
-          </a:xfrm>
-          <a:prstGeom prst="rect">
-            <a:avLst/>
-          </a:prstGeom>
-          <a:noFill/>
-        </p:spPr>
-        <p:txBody>
-          <a:bodyPr wrap="none">
-            <a:spAutoFit/>
-          </a:bodyPr>
-          <a:lstStyle/>
-          <a:p>
-            <a:pPr>
-              <a:defRPr sz="2400">
-                <a:solidFill>
-                  <a:srgbClr val="757575"/>
-                </a:solidFill>
-                <a:latin typeface="Hiragino Sans"/>
-              </a:defRPr>
-            </a:pPr>
-            <a:r>
-              <a:t>他の儲け方 (手数料ビジネス)</a:t>
-            </a:r>
-          </a:p>
-        </p:txBody>
-      </p:sp>
-      <p:sp>
-        <p:nvSpPr>
-          <p:cNvPr id="6" name="TextBox 5"/>
           <p:cNvSpPr txBox="1"/>
           <p:nvPr/>
         </p:nvSpPr>
@@ -4676,14 +4531,14 @@
       </p:sp>
       <p:sp>
         <p:nvSpPr>
-          <p:cNvPr id="7" name="TextBox 6"/>
+          <p:cNvPr id="6" name="TextBox 5"/>
           <p:cNvSpPr txBox="1"/>
           <p:nvPr/>
         </p:nvSpPr>
         <p:spPr>
           <a:xfrm>
-            <a:off x="457200" y="2743200"/>
-            <a:ext cx="11277295" cy="3474720"/>
+            <a:off x="365760" y="2743200"/>
+            <a:ext cx="11430000" cy="3474720"/>
           </a:xfrm>
           <a:prstGeom prst="rect">
             <a:avLst/>
@@ -4852,8 +4707,8 @@
         </p:nvSpPr>
         <p:spPr>
           <a:xfrm>
-            <a:off x="457200" y="6492240"/>
-            <a:ext cx="4572000" cy="274320"/>
+            <a:off x="457200" y="548640"/>
+            <a:ext cx="10972800" cy="914400"/>
           </a:xfrm>
           <a:prstGeom prst="rect">
             <a:avLst/>
@@ -4867,7 +4722,7 @@
           <a:lstStyle/>
           <a:p>
             <a:pPr>
-              <a:defRPr sz="1200">
+              <a:defRPr sz="2400">
                 <a:solidFill>
                   <a:srgbClr val="757575"/>
                 </a:solidFill>
@@ -4875,7 +4730,7 @@
               </a:defRPr>
             </a:pPr>
             <a:r>
-              <a:t>銀行業界の基礎知識 - 易化版</a:t>
+              <a:t>銀行のバランスシート (持ち物リスト)</a:t>
             </a:r>
           </a:p>
         </p:txBody>
@@ -4883,42 +4738,6 @@
       <p:sp>
         <p:nvSpPr>
           <p:cNvPr id="5" name="TextBox 4"/>
-          <p:cNvSpPr txBox="1"/>
-          <p:nvPr/>
-        </p:nvSpPr>
-        <p:spPr>
-          <a:xfrm>
-            <a:off x="457200" y="548640"/>
-            <a:ext cx="10972800" cy="914400"/>
-          </a:xfrm>
-          <a:prstGeom prst="rect">
-            <a:avLst/>
-          </a:prstGeom>
-          <a:noFill/>
-        </p:spPr>
-        <p:txBody>
-          <a:bodyPr wrap="none">
-            <a:spAutoFit/>
-          </a:bodyPr>
-          <a:lstStyle/>
-          <a:p>
-            <a:pPr>
-              <a:defRPr sz="2400">
-                <a:solidFill>
-                  <a:srgbClr val="757575"/>
-                </a:solidFill>
-                <a:latin typeface="Hiragino Sans"/>
-              </a:defRPr>
-            </a:pPr>
-            <a:r>
-              <a:t>銀行のバランスシート (持ち物リスト)</a:t>
-            </a:r>
-          </a:p>
-        </p:txBody>
-      </p:sp>
-      <p:sp>
-        <p:nvSpPr>
-          <p:cNvPr id="6" name="TextBox 5"/>
           <p:cNvSpPr txBox="1"/>
           <p:nvPr/>
         </p:nvSpPr>
@@ -4954,7 +4773,7 @@
       </p:sp>
       <p:sp>
         <p:nvSpPr>
-          <p:cNvPr id="7" name="Rectangle 6"/>
+          <p:cNvPr id="6" name="Rectangle 5"/>
           <p:cNvSpPr/>
           <p:nvPr/>
         </p:nvSpPr>
@@ -5013,7 +4832,7 @@
       </p:sp>
       <p:sp>
         <p:nvSpPr>
-          <p:cNvPr id="8" name="Rectangle 7"/>
+          <p:cNvPr id="7" name="Rectangle 6"/>
           <p:cNvSpPr/>
           <p:nvPr/>
         </p:nvSpPr>
@@ -5067,7 +4886,7 @@
       </p:sp>
       <p:sp>
         <p:nvSpPr>
-          <p:cNvPr id="9" name="TextBox 8"/>
+          <p:cNvPr id="8" name="TextBox 7"/>
           <p:cNvSpPr txBox="1"/>
           <p:nvPr/>
         </p:nvSpPr>
@@ -5372,8 +5191,8 @@
         </p:nvSpPr>
         <p:spPr>
           <a:xfrm>
-            <a:off x="457200" y="6492240"/>
-            <a:ext cx="4572000" cy="274320"/>
+            <a:off x="457200" y="548640"/>
+            <a:ext cx="10972800" cy="914400"/>
           </a:xfrm>
           <a:prstGeom prst="rect">
             <a:avLst/>
@@ -5387,7 +5206,7 @@
           <a:lstStyle/>
           <a:p>
             <a:pPr>
-              <a:defRPr sz="1200">
+              <a:defRPr sz="2400">
                 <a:solidFill>
                   <a:srgbClr val="757575"/>
                 </a:solidFill>
@@ -5395,7 +5214,7 @@
               </a:defRPr>
             </a:pPr>
             <a:r>
-              <a:t>銀行業界の基礎知識 - 易化版</a:t>
+              <a:t>銀行の仲間たち</a:t>
             </a:r>
           </a:p>
         </p:txBody>
@@ -5403,42 +5222,6 @@
       <p:sp>
         <p:nvSpPr>
           <p:cNvPr id="5" name="TextBox 4"/>
-          <p:cNvSpPr txBox="1"/>
-          <p:nvPr/>
-        </p:nvSpPr>
-        <p:spPr>
-          <a:xfrm>
-            <a:off x="457200" y="548640"/>
-            <a:ext cx="10972800" cy="914400"/>
-          </a:xfrm>
-          <a:prstGeom prst="rect">
-            <a:avLst/>
-          </a:prstGeom>
-          <a:noFill/>
-        </p:spPr>
-        <p:txBody>
-          <a:bodyPr wrap="none">
-            <a:spAutoFit/>
-          </a:bodyPr>
-          <a:lstStyle/>
-          <a:p>
-            <a:pPr>
-              <a:defRPr sz="2400">
-                <a:solidFill>
-                  <a:srgbClr val="757575"/>
-                </a:solidFill>
-                <a:latin typeface="Hiragino Sans"/>
-              </a:defRPr>
-            </a:pPr>
-            <a:r>
-              <a:t>銀行の仲間たち</a:t>
-            </a:r>
-          </a:p>
-        </p:txBody>
-      </p:sp>
-      <p:sp>
-        <p:nvSpPr>
-          <p:cNvPr id="6" name="TextBox 5"/>
           <p:cNvSpPr txBox="1"/>
           <p:nvPr/>
         </p:nvSpPr>
@@ -5474,7 +5257,7 @@
       </p:sp>
       <p:sp>
         <p:nvSpPr>
-          <p:cNvPr id="7" name="Rounded Rectangle 6"/>
+          <p:cNvPr id="6" name="Rounded Rectangle 5"/>
           <p:cNvSpPr/>
           <p:nvPr/>
         </p:nvSpPr>
@@ -5528,7 +5311,7 @@
       </p:sp>
       <p:sp>
         <p:nvSpPr>
-          <p:cNvPr id="8" name="Rounded Rectangle 7"/>
+          <p:cNvPr id="7" name="Rounded Rectangle 6"/>
           <p:cNvSpPr/>
           <p:nvPr/>
         </p:nvSpPr>
@@ -5587,7 +5370,7 @@
       </p:sp>
       <p:sp>
         <p:nvSpPr>
-          <p:cNvPr id="9" name="Rounded Rectangle 8"/>
+          <p:cNvPr id="8" name="Rounded Rectangle 7"/>
           <p:cNvSpPr/>
           <p:nvPr/>
         </p:nvSpPr>
@@ -5646,7 +5429,7 @@
       </p:sp>
       <p:sp>
         <p:nvSpPr>
-          <p:cNvPr id="10" name="Rounded Rectangle 9"/>
+          <p:cNvPr id="9" name="Rounded Rectangle 8"/>
           <p:cNvSpPr/>
           <p:nvPr/>
         </p:nvSpPr>
@@ -5809,8 +5592,8 @@
         </p:nvSpPr>
         <p:spPr>
           <a:xfrm>
-            <a:off x="457200" y="6492240"/>
-            <a:ext cx="4572000" cy="274320"/>
+            <a:off x="457200" y="548640"/>
+            <a:ext cx="10972800" cy="914400"/>
           </a:xfrm>
           <a:prstGeom prst="rect">
             <a:avLst/>
@@ -5824,7 +5607,7 @@
           <a:lstStyle/>
           <a:p>
             <a:pPr>
-              <a:defRPr sz="1200">
+              <a:defRPr sz="2400">
                 <a:solidFill>
                   <a:srgbClr val="757575"/>
                 </a:solidFill>
@@ -5832,7 +5615,7 @@
               </a:defRPr>
             </a:pPr>
             <a:r>
-              <a:t>銀行業界の基礎知識 - 易化版</a:t>
+              <a:t>今の銀行の悩み：金利がほぼ0円</a:t>
             </a:r>
           </a:p>
         </p:txBody>
@@ -5840,42 +5623,6 @@
       <p:sp>
         <p:nvSpPr>
           <p:cNvPr id="5" name="TextBox 4"/>
-          <p:cNvSpPr txBox="1"/>
-          <p:nvPr/>
-        </p:nvSpPr>
-        <p:spPr>
-          <a:xfrm>
-            <a:off x="457200" y="548640"/>
-            <a:ext cx="10972800" cy="914400"/>
-          </a:xfrm>
-          <a:prstGeom prst="rect">
-            <a:avLst/>
-          </a:prstGeom>
-          <a:noFill/>
-        </p:spPr>
-        <p:txBody>
-          <a:bodyPr wrap="none">
-            <a:spAutoFit/>
-          </a:bodyPr>
-          <a:lstStyle/>
-          <a:p>
-            <a:pPr>
-              <a:defRPr sz="2400">
-                <a:solidFill>
-                  <a:srgbClr val="757575"/>
-                </a:solidFill>
-                <a:latin typeface="Hiragino Sans"/>
-              </a:defRPr>
-            </a:pPr>
-            <a:r>
-              <a:t>今の銀行の悩み：金利がほぼ0円</a:t>
-            </a:r>
-          </a:p>
-        </p:txBody>
-      </p:sp>
-      <p:sp>
-        <p:nvSpPr>
-          <p:cNvPr id="6" name="TextBox 5"/>
           <p:cNvSpPr txBox="1"/>
           <p:nvPr/>
         </p:nvSpPr>
@@ -5911,14 +5658,14 @@
       </p:sp>
       <p:sp>
         <p:nvSpPr>
-          <p:cNvPr id="7" name="TextBox 6"/>
+          <p:cNvPr id="6" name="TextBox 5"/>
           <p:cNvSpPr txBox="1"/>
           <p:nvPr/>
         </p:nvSpPr>
         <p:spPr>
           <a:xfrm>
-            <a:off x="457200" y="2743200"/>
-            <a:ext cx="11277295" cy="3474720"/>
+            <a:off x="365760" y="2743200"/>
+            <a:ext cx="11430000" cy="3474720"/>
           </a:xfrm>
           <a:prstGeom prst="rect">
             <a:avLst/>
@@ -5944,7 +5691,7 @@
               </a:defRPr>
             </a:pPr>
             <a:r>
-              <a:t>● 今は、お金を借りやすいように「金利」がすごく低く設定されています。</a:t>
+              <a:t>● 今は金利が低いため、企業に貸しても「利息」がほとんど貰えません。</a:t>
             </a:r>
           </a:p>
           <a:p>
@@ -5960,23 +5707,7 @@
               </a:defRPr>
             </a:pPr>
             <a:r>
-              <a:t>● つまり、企業にお金を貸しても「利息（お礼）」がほとんど貰えません。</a:t>
-            </a:r>
-          </a:p>
-          <a:p>
-            <a:pPr>
-              <a:spcAft>
-                <a:spcPts val="2400"/>
-              </a:spcAft>
-              <a:defRPr sz="2600">
-                <a:solidFill>
-                  <a:srgbClr val="1C1B19"/>
-                </a:solidFill>
-                <a:latin typeface="Hiragino Sans"/>
-              </a:defRPr>
-            </a:pPr>
-            <a:r>
-              <a:t>● 100万円を1年預けても、チロルチョコ1個買えないほどの低金利時代です。</a:t>
+              <a:t>● 100万円を1年預けても、チロルチョコ1個買えない時代です。</a:t>
             </a:r>
           </a:p>
         </p:txBody>
@@ -6087,8 +5818,8 @@
         </p:nvSpPr>
         <p:spPr>
           <a:xfrm>
-            <a:off x="457200" y="6492240"/>
-            <a:ext cx="4572000" cy="274320"/>
+            <a:off x="457200" y="548640"/>
+            <a:ext cx="10972800" cy="914400"/>
           </a:xfrm>
           <a:prstGeom prst="rect">
             <a:avLst/>
@@ -6102,7 +5833,7 @@
           <a:lstStyle/>
           <a:p>
             <a:pPr>
-              <a:defRPr sz="1200">
+              <a:defRPr sz="2400">
                 <a:solidFill>
                   <a:srgbClr val="757575"/>
                 </a:solidFill>
@@ -6110,7 +5841,7 @@
               </a:defRPr>
             </a:pPr>
             <a:r>
-              <a:t>銀行業界の基礎知識 - 易化版</a:t>
+              <a:t>地方銀行の「合体」と「統廃合」</a:t>
             </a:r>
           </a:p>
         </p:txBody>
@@ -6118,42 +5849,6 @@
       <p:sp>
         <p:nvSpPr>
           <p:cNvPr id="5" name="TextBox 4"/>
-          <p:cNvSpPr txBox="1"/>
-          <p:nvPr/>
-        </p:nvSpPr>
-        <p:spPr>
-          <a:xfrm>
-            <a:off x="457200" y="548640"/>
-            <a:ext cx="10972800" cy="914400"/>
-          </a:xfrm>
-          <a:prstGeom prst="rect">
-            <a:avLst/>
-          </a:prstGeom>
-          <a:noFill/>
-        </p:spPr>
-        <p:txBody>
-          <a:bodyPr wrap="none">
-            <a:spAutoFit/>
-          </a:bodyPr>
-          <a:lstStyle/>
-          <a:p>
-            <a:pPr>
-              <a:defRPr sz="2400">
-                <a:solidFill>
-                  <a:srgbClr val="757575"/>
-                </a:solidFill>
-                <a:latin typeface="Hiragino Sans"/>
-              </a:defRPr>
-            </a:pPr>
-            <a:r>
-              <a:t>地方銀行の「合体」と「統廃合」</a:t>
-            </a:r>
-          </a:p>
-        </p:txBody>
-      </p:sp>
-      <p:sp>
-        <p:nvSpPr>
-          <p:cNvPr id="6" name="TextBox 5"/>
           <p:cNvSpPr txBox="1"/>
           <p:nvPr/>
         </p:nvSpPr>
@@ -6189,14 +5884,14 @@
       </p:sp>
       <p:sp>
         <p:nvSpPr>
-          <p:cNvPr id="7" name="TextBox 6"/>
+          <p:cNvPr id="6" name="TextBox 5"/>
           <p:cNvSpPr txBox="1"/>
           <p:nvPr/>
         </p:nvSpPr>
         <p:spPr>
           <a:xfrm>
-            <a:off x="457200" y="2743200"/>
-            <a:ext cx="11277295" cy="3474720"/>
+            <a:off x="365760" y="2743200"/>
+            <a:ext cx="11430000" cy="3474720"/>
           </a:xfrm>
           <a:prstGeom prst="rect">
             <a:avLst/>
@@ -6519,8 +6214,8 @@
         </p:nvSpPr>
         <p:spPr>
           <a:xfrm>
-            <a:off x="457200" y="6492240"/>
-            <a:ext cx="4572000" cy="274320"/>
+            <a:off x="457200" y="548640"/>
+            <a:ext cx="10972800" cy="914400"/>
           </a:xfrm>
           <a:prstGeom prst="rect">
             <a:avLst/>
@@ -6534,7 +6229,7 @@
           <a:lstStyle/>
           <a:p>
             <a:pPr>
-              <a:defRPr sz="1200">
+              <a:defRPr sz="2400">
                 <a:solidFill>
                   <a:srgbClr val="757575"/>
                 </a:solidFill>
@@ -6542,7 +6237,7 @@
               </a:defRPr>
             </a:pPr>
             <a:r>
-              <a:t>銀行業界の基礎知識 - 易化版</a:t>
+              <a:t>導入</a:t>
             </a:r>
           </a:p>
         </p:txBody>
@@ -6550,42 +6245,6 @@
       <p:sp>
         <p:nvSpPr>
           <p:cNvPr id="5" name="TextBox 4"/>
-          <p:cNvSpPr txBox="1"/>
-          <p:nvPr/>
-        </p:nvSpPr>
-        <p:spPr>
-          <a:xfrm>
-            <a:off x="457200" y="548640"/>
-            <a:ext cx="10972800" cy="914400"/>
-          </a:xfrm>
-          <a:prstGeom prst="rect">
-            <a:avLst/>
-          </a:prstGeom>
-          <a:noFill/>
-        </p:spPr>
-        <p:txBody>
-          <a:bodyPr wrap="none">
-            <a:spAutoFit/>
-          </a:bodyPr>
-          <a:lstStyle/>
-          <a:p>
-            <a:pPr>
-              <a:defRPr sz="2400">
-                <a:solidFill>
-                  <a:srgbClr val="757575"/>
-                </a:solidFill>
-                <a:latin typeface="Hiragino Sans"/>
-              </a:defRPr>
-            </a:pPr>
-            <a:r>
-              <a:t>導入</a:t>
-            </a:r>
-          </a:p>
-        </p:txBody>
-      </p:sp>
-      <p:sp>
-        <p:nvSpPr>
-          <p:cNvPr id="6" name="TextBox 5"/>
           <p:cNvSpPr txBox="1"/>
           <p:nvPr/>
         </p:nvSpPr>
@@ -6621,14 +6280,14 @@
       </p:sp>
       <p:sp>
         <p:nvSpPr>
-          <p:cNvPr id="7" name="TextBox 6"/>
+          <p:cNvPr id="6" name="TextBox 5"/>
           <p:cNvSpPr txBox="1"/>
           <p:nvPr/>
         </p:nvSpPr>
         <p:spPr>
           <a:xfrm>
-            <a:off x="457200" y="2743200"/>
-            <a:ext cx="11277295" cy="3474720"/>
+            <a:off x="365760" y="2743200"/>
+            <a:ext cx="11430000" cy="3474720"/>
           </a:xfrm>
           <a:prstGeom prst="rect">
             <a:avLst/>
@@ -6813,8 +6472,8 @@
         </p:nvSpPr>
         <p:spPr>
           <a:xfrm>
-            <a:off x="457200" y="6492240"/>
-            <a:ext cx="4572000" cy="274320"/>
+            <a:off x="457200" y="548640"/>
+            <a:ext cx="10972800" cy="914400"/>
           </a:xfrm>
           <a:prstGeom prst="rect">
             <a:avLst/>
@@ -6828,7 +6487,7 @@
           <a:lstStyle/>
           <a:p>
             <a:pPr>
-              <a:defRPr sz="1200">
+              <a:defRPr sz="2400">
                 <a:solidFill>
                   <a:srgbClr val="757575"/>
                 </a:solidFill>
@@ -6836,7 +6495,7 @@
               </a:defRPr>
             </a:pPr>
             <a:r>
-              <a:t>銀行業界の基礎知識 - 易化版</a:t>
+              <a:t>スマホ決済の台頭 (PayPayやメルペイ)</a:t>
             </a:r>
           </a:p>
         </p:txBody>
@@ -6844,42 +6503,6 @@
       <p:sp>
         <p:nvSpPr>
           <p:cNvPr id="5" name="TextBox 4"/>
-          <p:cNvSpPr txBox="1"/>
-          <p:nvPr/>
-        </p:nvSpPr>
-        <p:spPr>
-          <a:xfrm>
-            <a:off x="457200" y="548640"/>
-            <a:ext cx="10972800" cy="914400"/>
-          </a:xfrm>
-          <a:prstGeom prst="rect">
-            <a:avLst/>
-          </a:prstGeom>
-          <a:noFill/>
-        </p:spPr>
-        <p:txBody>
-          <a:bodyPr wrap="none">
-            <a:spAutoFit/>
-          </a:bodyPr>
-          <a:lstStyle/>
-          <a:p>
-            <a:pPr>
-              <a:defRPr sz="2400">
-                <a:solidFill>
-                  <a:srgbClr val="757575"/>
-                </a:solidFill>
-                <a:latin typeface="Hiragino Sans"/>
-              </a:defRPr>
-            </a:pPr>
-            <a:r>
-              <a:t>スマホ決済の台頭 (PayPayやメルペイ)</a:t>
-            </a:r>
-          </a:p>
-        </p:txBody>
-      </p:sp>
-      <p:sp>
-        <p:nvSpPr>
-          <p:cNvPr id="6" name="TextBox 5"/>
           <p:cNvSpPr txBox="1"/>
           <p:nvPr/>
         </p:nvSpPr>
@@ -6915,14 +6538,14 @@
       </p:sp>
       <p:sp>
         <p:nvSpPr>
-          <p:cNvPr id="7" name="TextBox 6"/>
+          <p:cNvPr id="6" name="TextBox 5"/>
           <p:cNvSpPr txBox="1"/>
           <p:nvPr/>
         </p:nvSpPr>
         <p:spPr>
           <a:xfrm>
-            <a:off x="457200" y="2743200"/>
-            <a:ext cx="11277295" cy="3474720"/>
+            <a:off x="365760" y="2743200"/>
+            <a:ext cx="11430000" cy="3474720"/>
           </a:xfrm>
           <a:prstGeom prst="rect">
             <a:avLst/>
@@ -7075,8 +6698,8 @@
         </p:nvSpPr>
         <p:spPr>
           <a:xfrm>
-            <a:off x="457200" y="6492240"/>
-            <a:ext cx="4572000" cy="274320"/>
+            <a:off x="457200" y="548640"/>
+            <a:ext cx="10972800" cy="914400"/>
           </a:xfrm>
           <a:prstGeom prst="rect">
             <a:avLst/>
@@ -7090,7 +6713,7 @@
           <a:lstStyle/>
           <a:p>
             <a:pPr>
-              <a:defRPr sz="1200">
+              <a:defRPr sz="2400">
                 <a:solidFill>
                   <a:srgbClr val="757575"/>
                 </a:solidFill>
@@ -7098,7 +6721,7 @@
               </a:defRPr>
             </a:pPr>
             <a:r>
-              <a:t>銀行業界の基礎知識 - 易化版</a:t>
+              <a:t>ネット銀行の急成長</a:t>
             </a:r>
           </a:p>
         </p:txBody>
@@ -7106,42 +6729,6 @@
       <p:sp>
         <p:nvSpPr>
           <p:cNvPr id="5" name="TextBox 4"/>
-          <p:cNvSpPr txBox="1"/>
-          <p:nvPr/>
-        </p:nvSpPr>
-        <p:spPr>
-          <a:xfrm>
-            <a:off x="457200" y="548640"/>
-            <a:ext cx="10972800" cy="914400"/>
-          </a:xfrm>
-          <a:prstGeom prst="rect">
-            <a:avLst/>
-          </a:prstGeom>
-          <a:noFill/>
-        </p:spPr>
-        <p:txBody>
-          <a:bodyPr wrap="none">
-            <a:spAutoFit/>
-          </a:bodyPr>
-          <a:lstStyle/>
-          <a:p>
-            <a:pPr>
-              <a:defRPr sz="2400">
-                <a:solidFill>
-                  <a:srgbClr val="757575"/>
-                </a:solidFill>
-                <a:latin typeface="Hiragino Sans"/>
-              </a:defRPr>
-            </a:pPr>
-            <a:r>
-              <a:t>ネット銀行の急成長</a:t>
-            </a:r>
-          </a:p>
-        </p:txBody>
-      </p:sp>
-      <p:sp>
-        <p:nvSpPr>
-          <p:cNvPr id="6" name="TextBox 5"/>
           <p:cNvSpPr txBox="1"/>
           <p:nvPr/>
         </p:nvSpPr>
@@ -7177,14 +6764,14 @@
       </p:sp>
       <p:sp>
         <p:nvSpPr>
-          <p:cNvPr id="7" name="TextBox 6"/>
+          <p:cNvPr id="6" name="TextBox 5"/>
           <p:cNvSpPr txBox="1"/>
           <p:nvPr/>
         </p:nvSpPr>
         <p:spPr>
           <a:xfrm>
-            <a:off x="457200" y="2743200"/>
-            <a:ext cx="11277295" cy="3474720"/>
+            <a:off x="365760" y="2743200"/>
+            <a:ext cx="11430000" cy="3474720"/>
           </a:xfrm>
           <a:prstGeom prst="rect">
             <a:avLst/>
@@ -7337,8 +6924,8 @@
         </p:nvSpPr>
         <p:spPr>
           <a:xfrm>
-            <a:off x="457200" y="6492240"/>
-            <a:ext cx="4572000" cy="274320"/>
+            <a:off x="457200" y="548640"/>
+            <a:ext cx="10972800" cy="914400"/>
           </a:xfrm>
           <a:prstGeom prst="rect">
             <a:avLst/>
@@ -7352,7 +6939,7 @@
           <a:lstStyle/>
           <a:p>
             <a:pPr>
-              <a:defRPr sz="1200">
+              <a:defRPr sz="2400">
                 <a:solidFill>
                   <a:srgbClr val="757575"/>
                 </a:solidFill>
@@ -7360,7 +6947,7 @@
               </a:defRPr>
             </a:pPr>
             <a:r>
-              <a:t>銀行業界の基礎知識 - 易化版</a:t>
+              <a:t>超強力なライバル：IT企業やカフェ</a:t>
             </a:r>
           </a:p>
         </p:txBody>
@@ -7368,42 +6955,6 @@
       <p:sp>
         <p:nvSpPr>
           <p:cNvPr id="5" name="TextBox 4"/>
-          <p:cNvSpPr txBox="1"/>
-          <p:nvPr/>
-        </p:nvSpPr>
-        <p:spPr>
-          <a:xfrm>
-            <a:off x="457200" y="548640"/>
-            <a:ext cx="10972800" cy="914400"/>
-          </a:xfrm>
-          <a:prstGeom prst="rect">
-            <a:avLst/>
-          </a:prstGeom>
-          <a:noFill/>
-        </p:spPr>
-        <p:txBody>
-          <a:bodyPr wrap="none">
-            <a:spAutoFit/>
-          </a:bodyPr>
-          <a:lstStyle/>
-          <a:p>
-            <a:pPr>
-              <a:defRPr sz="2400">
-                <a:solidFill>
-                  <a:srgbClr val="757575"/>
-                </a:solidFill>
-                <a:latin typeface="Hiragino Sans"/>
-              </a:defRPr>
-            </a:pPr>
-            <a:r>
-              <a:t>超強力なライバル：IT企業やカフェ</a:t>
-            </a:r>
-          </a:p>
-        </p:txBody>
-      </p:sp>
-      <p:sp>
-        <p:nvSpPr>
-          <p:cNvPr id="6" name="TextBox 5"/>
           <p:cNvSpPr txBox="1"/>
           <p:nvPr/>
         </p:nvSpPr>
@@ -7439,14 +6990,14 @@
       </p:sp>
       <p:sp>
         <p:nvSpPr>
-          <p:cNvPr id="7" name="TextBox 6"/>
+          <p:cNvPr id="6" name="TextBox 5"/>
           <p:cNvSpPr txBox="1"/>
           <p:nvPr/>
         </p:nvSpPr>
         <p:spPr>
           <a:xfrm>
-            <a:off x="457200" y="2743200"/>
-            <a:ext cx="11277295" cy="3474720"/>
+            <a:off x="365760" y="2743200"/>
+            <a:ext cx="11430000" cy="3474720"/>
           </a:xfrm>
           <a:prstGeom prst="rect">
             <a:avLst/>
@@ -7785,8 +7336,8 @@
         </p:nvSpPr>
         <p:spPr>
           <a:xfrm>
-            <a:off x="457200" y="6492240"/>
-            <a:ext cx="4572000" cy="274320"/>
+            <a:off x="457200" y="548640"/>
+            <a:ext cx="10972800" cy="914400"/>
           </a:xfrm>
           <a:prstGeom prst="rect">
             <a:avLst/>
@@ -7800,7 +7351,7 @@
           <a:lstStyle/>
           <a:p>
             <a:pPr>
-              <a:defRPr sz="1200">
+              <a:defRPr sz="2400">
                 <a:solidFill>
                   <a:srgbClr val="757575"/>
                 </a:solidFill>
@@ -7808,7 +7359,7 @@
               </a:defRPr>
             </a:pPr>
             <a:r>
-              <a:t>銀行業界の基礎知識 - 易化版</a:t>
+              <a:t>DX (デジタル化) の推進</a:t>
             </a:r>
           </a:p>
         </p:txBody>
@@ -7816,42 +7367,6 @@
       <p:sp>
         <p:nvSpPr>
           <p:cNvPr id="5" name="TextBox 4"/>
-          <p:cNvSpPr txBox="1"/>
-          <p:nvPr/>
-        </p:nvSpPr>
-        <p:spPr>
-          <a:xfrm>
-            <a:off x="457200" y="548640"/>
-            <a:ext cx="10972800" cy="914400"/>
-          </a:xfrm>
-          <a:prstGeom prst="rect">
-            <a:avLst/>
-          </a:prstGeom>
-          <a:noFill/>
-        </p:spPr>
-        <p:txBody>
-          <a:bodyPr wrap="none">
-            <a:spAutoFit/>
-          </a:bodyPr>
-          <a:lstStyle/>
-          <a:p>
-            <a:pPr>
-              <a:defRPr sz="2400">
-                <a:solidFill>
-                  <a:srgbClr val="757575"/>
-                </a:solidFill>
-                <a:latin typeface="Hiragino Sans"/>
-              </a:defRPr>
-            </a:pPr>
-            <a:r>
-              <a:t>DX (デジタル化) の推進</a:t>
-            </a:r>
-          </a:p>
-        </p:txBody>
-      </p:sp>
-      <p:sp>
-        <p:nvSpPr>
-          <p:cNvPr id="6" name="TextBox 5"/>
           <p:cNvSpPr txBox="1"/>
           <p:nvPr/>
         </p:nvSpPr>
@@ -7887,14 +7402,14 @@
       </p:sp>
       <p:sp>
         <p:nvSpPr>
-          <p:cNvPr id="7" name="TextBox 6"/>
+          <p:cNvPr id="6" name="TextBox 5"/>
           <p:cNvSpPr txBox="1"/>
           <p:nvPr/>
         </p:nvSpPr>
         <p:spPr>
           <a:xfrm>
-            <a:off x="457200" y="2743200"/>
-            <a:ext cx="11277295" cy="3474720"/>
+            <a:off x="365760" y="2743200"/>
+            <a:ext cx="11430000" cy="3474720"/>
           </a:xfrm>
           <a:prstGeom prst="rect">
             <a:avLst/>
@@ -8047,8 +7562,8 @@
         </p:nvSpPr>
         <p:spPr>
           <a:xfrm>
-            <a:off x="457200" y="6492240"/>
-            <a:ext cx="4572000" cy="274320"/>
+            <a:off x="457200" y="548640"/>
+            <a:ext cx="10972800" cy="914400"/>
           </a:xfrm>
           <a:prstGeom prst="rect">
             <a:avLst/>
@@ -8062,7 +7577,7 @@
           <a:lstStyle/>
           <a:p>
             <a:pPr>
-              <a:defRPr sz="1200">
+              <a:defRPr sz="2400">
                 <a:solidFill>
                   <a:srgbClr val="757575"/>
                 </a:solidFill>
@@ -8070,7 +7585,7 @@
               </a:defRPr>
             </a:pPr>
             <a:r>
-              <a:t>銀行業界の基礎知識 - 易化版</a:t>
+              <a:t>これからのビジネスモデル</a:t>
             </a:r>
           </a:p>
         </p:txBody>
@@ -8078,42 +7593,6 @@
       <p:sp>
         <p:nvSpPr>
           <p:cNvPr id="5" name="TextBox 4"/>
-          <p:cNvSpPr txBox="1"/>
-          <p:nvPr/>
-        </p:nvSpPr>
-        <p:spPr>
-          <a:xfrm>
-            <a:off x="457200" y="548640"/>
-            <a:ext cx="10972800" cy="914400"/>
-          </a:xfrm>
-          <a:prstGeom prst="rect">
-            <a:avLst/>
-          </a:prstGeom>
-          <a:noFill/>
-        </p:spPr>
-        <p:txBody>
-          <a:bodyPr wrap="none">
-            <a:spAutoFit/>
-          </a:bodyPr>
-          <a:lstStyle/>
-          <a:p>
-            <a:pPr>
-              <a:defRPr sz="2400">
-                <a:solidFill>
-                  <a:srgbClr val="757575"/>
-                </a:solidFill>
-                <a:latin typeface="Hiragino Sans"/>
-              </a:defRPr>
-            </a:pPr>
-            <a:r>
-              <a:t>これからのビジネスモデル</a:t>
-            </a:r>
-          </a:p>
-        </p:txBody>
-      </p:sp>
-      <p:sp>
-        <p:nvSpPr>
-          <p:cNvPr id="6" name="TextBox 5"/>
           <p:cNvSpPr txBox="1"/>
           <p:nvPr/>
         </p:nvSpPr>
@@ -8149,14 +7628,14 @@
       </p:sp>
       <p:sp>
         <p:nvSpPr>
-          <p:cNvPr id="7" name="TextBox 6"/>
+          <p:cNvPr id="6" name="TextBox 5"/>
           <p:cNvSpPr txBox="1"/>
           <p:nvPr/>
         </p:nvSpPr>
         <p:spPr>
           <a:xfrm>
-            <a:off x="457200" y="2743200"/>
-            <a:ext cx="11277295" cy="3474720"/>
+            <a:off x="365760" y="2743200"/>
+            <a:ext cx="11430000" cy="3474720"/>
           </a:xfrm>
           <a:prstGeom prst="rect">
             <a:avLst/>
@@ -8309,8 +7788,8 @@
         </p:nvSpPr>
         <p:spPr>
           <a:xfrm>
-            <a:off x="457200" y="6492240"/>
-            <a:ext cx="4572000" cy="274320"/>
+            <a:off x="457200" y="548640"/>
+            <a:ext cx="10972800" cy="914400"/>
           </a:xfrm>
           <a:prstGeom prst="rect">
             <a:avLst/>
@@ -8324,7 +7803,7 @@
           <a:lstStyle/>
           <a:p>
             <a:pPr>
-              <a:defRPr sz="1200">
+              <a:defRPr sz="2400">
                 <a:solidFill>
                   <a:srgbClr val="757575"/>
                 </a:solidFill>
@@ -8332,7 +7811,7 @@
               </a:defRPr>
             </a:pPr>
             <a:r>
-              <a:t>銀行業界の基礎知識 - 易化版</a:t>
+              <a:t>2030年の銀行像</a:t>
             </a:r>
           </a:p>
         </p:txBody>
@@ -8340,42 +7819,6 @@
       <p:sp>
         <p:nvSpPr>
           <p:cNvPr id="5" name="TextBox 4"/>
-          <p:cNvSpPr txBox="1"/>
-          <p:nvPr/>
-        </p:nvSpPr>
-        <p:spPr>
-          <a:xfrm>
-            <a:off x="457200" y="548640"/>
-            <a:ext cx="10972800" cy="914400"/>
-          </a:xfrm>
-          <a:prstGeom prst="rect">
-            <a:avLst/>
-          </a:prstGeom>
-          <a:noFill/>
-        </p:spPr>
-        <p:txBody>
-          <a:bodyPr wrap="none">
-            <a:spAutoFit/>
-          </a:bodyPr>
-          <a:lstStyle/>
-          <a:p>
-            <a:pPr>
-              <a:defRPr sz="2400">
-                <a:solidFill>
-                  <a:srgbClr val="757575"/>
-                </a:solidFill>
-                <a:latin typeface="Hiragino Sans"/>
-              </a:defRPr>
-            </a:pPr>
-            <a:r>
-              <a:t>2030年の銀行像</a:t>
-            </a:r>
-          </a:p>
-        </p:txBody>
-      </p:sp>
-      <p:sp>
-        <p:nvSpPr>
-          <p:cNvPr id="6" name="TextBox 5"/>
           <p:cNvSpPr txBox="1"/>
           <p:nvPr/>
         </p:nvSpPr>
@@ -8411,14 +7854,14 @@
       </p:sp>
       <p:sp>
         <p:nvSpPr>
-          <p:cNvPr id="7" name="TextBox 6"/>
+          <p:cNvPr id="6" name="TextBox 5"/>
           <p:cNvSpPr txBox="1"/>
           <p:nvPr/>
         </p:nvSpPr>
         <p:spPr>
           <a:xfrm>
-            <a:off x="457200" y="2743200"/>
-            <a:ext cx="11277295" cy="3474720"/>
+            <a:off x="365760" y="2743200"/>
+            <a:ext cx="11430000" cy="3474720"/>
           </a:xfrm>
           <a:prstGeom prst="rect">
             <a:avLst/>
@@ -8630,7 +8073,7 @@
               </a:defRPr>
             </a:pPr>
             <a:r>
-              <a:t>まとめと問いかけ</a:t>
+              <a:t>まとめ</a:t>
             </a:r>
           </a:p>
         </p:txBody>
@@ -8741,8 +8184,8 @@
         </p:nvSpPr>
         <p:spPr>
           <a:xfrm>
-            <a:off x="457200" y="6492240"/>
-            <a:ext cx="4572000" cy="274320"/>
+            <a:off x="457200" y="548640"/>
+            <a:ext cx="10972800" cy="914400"/>
           </a:xfrm>
           <a:prstGeom prst="rect">
             <a:avLst/>
@@ -8756,15 +8199,15 @@
           <a:lstStyle/>
           <a:p>
             <a:pPr>
-              <a:defRPr sz="1200">
-                <a:solidFill>
-                  <a:srgbClr val="757575"/>
+              <a:defRPr sz="4000" b="1">
+                <a:solidFill>
+                  <a:srgbClr val="1C1B19"/>
                 </a:solidFill>
                 <a:latin typeface="Hiragino Sans"/>
               </a:defRPr>
             </a:pPr>
             <a:r>
-              <a:t>銀行業界の基礎知識 - 易化版</a:t>
+              <a:t>今日のまとめ</a:t>
             </a:r>
           </a:p>
         </p:txBody>
@@ -8772,42 +8215,6 @@
       <p:sp>
         <p:nvSpPr>
           <p:cNvPr id="5" name="TextBox 4"/>
-          <p:cNvSpPr txBox="1"/>
-          <p:nvPr/>
-        </p:nvSpPr>
-        <p:spPr>
-          <a:xfrm>
-            <a:off x="457200" y="548640"/>
-            <a:ext cx="10972800" cy="914400"/>
-          </a:xfrm>
-          <a:prstGeom prst="rect">
-            <a:avLst/>
-          </a:prstGeom>
-          <a:noFill/>
-        </p:spPr>
-        <p:txBody>
-          <a:bodyPr wrap="none">
-            <a:spAutoFit/>
-          </a:bodyPr>
-          <a:lstStyle/>
-          <a:p>
-            <a:pPr>
-              <a:defRPr sz="4000" b="1">
-                <a:solidFill>
-                  <a:srgbClr val="1C1B19"/>
-                </a:solidFill>
-                <a:latin typeface="Hiragino Sans"/>
-              </a:defRPr>
-            </a:pPr>
-            <a:r>
-              <a:t>今日のまとめ</a:t>
-            </a:r>
-          </a:p>
-        </p:txBody>
-      </p:sp>
-      <p:sp>
-        <p:nvSpPr>
-          <p:cNvPr id="6" name="TextBox 5"/>
           <p:cNvSpPr txBox="1"/>
           <p:nvPr/>
         </p:nvSpPr>
@@ -8889,284 +8296,6 @@
             </a:pPr>
             <a:r>
               <a:t>✔ これからはスマホの奥に溶け込む「見えない銀行」へと進化していく。</a:t>
-            </a:r>
-          </a:p>
-        </p:txBody>
-      </p:sp>
-    </p:spTree>
-  </p:cSld>
-  <p:clrMapOvr>
-    <a:masterClrMapping/>
-  </p:clrMapOvr>
-</p:sld>
-</file>
-
-<file path=ppt/slides/slide29.xml><?xml version="1.0" encoding="utf-8"?>
-<p:sld xmlns:a="http://schemas.openxmlformats.org/drawingml/2006/main" xmlns:p="http://schemas.openxmlformats.org/presentationml/2006/main" xmlns:r="http://schemas.openxmlformats.org/officeDocument/2006/relationships">
-  <p:cSld>
-    <p:spTree>
-      <p:nvGrpSpPr>
-        <p:cNvPr id="1" name=""/>
-        <p:cNvGrpSpPr/>
-        <p:nvPr/>
-      </p:nvGrpSpPr>
-      <p:grpSpPr/>
-      <p:sp>
-        <p:nvSpPr>
-          <p:cNvPr id="2" name="Rectangle 1"/>
-          <p:cNvSpPr/>
-          <p:nvPr/>
-        </p:nvSpPr>
-        <p:spPr>
-          <a:xfrm>
-            <a:off x="0" y="0"/>
-            <a:ext cx="12191695" cy="6858000"/>
-          </a:xfrm>
-          <a:prstGeom prst="rect">
-            <a:avLst/>
-          </a:prstGeom>
-          <a:solidFill>
-            <a:srgbClr val="FFFFFF"/>
-          </a:solidFill>
-        </p:spPr>
-        <p:style>
-          <a:lnRef idx="1">
-            <a:schemeClr val="accent1"/>
-          </a:lnRef>
-          <a:fillRef idx="3">
-            <a:schemeClr val="accent1"/>
-          </a:fillRef>
-          <a:effectRef idx="2">
-            <a:schemeClr val="accent1"/>
-          </a:effectRef>
-          <a:fontRef idx="minor">
-            <a:schemeClr val="lt1"/>
-          </a:fontRef>
-        </p:style>
-        <p:txBody>
-          <a:bodyPr rtlCol="0" anchor="ctr"/>
-          <a:lstStyle/>
-          <a:p>
-            <a:pPr algn="ctr"/>
-          </a:p>
-        </p:txBody>
-      </p:sp>
-      <p:sp>
-        <p:nvSpPr>
-          <p:cNvPr id="3" name="Rectangle 2"/>
-          <p:cNvSpPr/>
-          <p:nvPr/>
-        </p:nvSpPr>
-        <p:spPr>
-          <a:xfrm>
-            <a:off x="457200" y="365760"/>
-            <a:ext cx="11277295" cy="36576"/>
-          </a:xfrm>
-          <a:prstGeom prst="rect">
-            <a:avLst/>
-          </a:prstGeom>
-          <a:solidFill>
-            <a:srgbClr val="D0D0D0"/>
-          </a:solidFill>
-        </p:spPr>
-        <p:style>
-          <a:lnRef idx="1">
-            <a:schemeClr val="accent1"/>
-          </a:lnRef>
-          <a:fillRef idx="3">
-            <a:schemeClr val="accent1"/>
-          </a:fillRef>
-          <a:effectRef idx="2">
-            <a:schemeClr val="accent1"/>
-          </a:effectRef>
-          <a:fontRef idx="minor">
-            <a:schemeClr val="lt1"/>
-          </a:fontRef>
-        </p:style>
-        <p:txBody>
-          <a:bodyPr rtlCol="0" anchor="ctr"/>
-          <a:lstStyle/>
-          <a:p>
-            <a:pPr algn="ctr"/>
-          </a:p>
-        </p:txBody>
-      </p:sp>
-      <p:sp>
-        <p:nvSpPr>
-          <p:cNvPr id="4" name="TextBox 3"/>
-          <p:cNvSpPr txBox="1"/>
-          <p:nvPr/>
-        </p:nvSpPr>
-        <p:spPr>
-          <a:xfrm>
-            <a:off x="457200" y="6492240"/>
-            <a:ext cx="4572000" cy="274320"/>
-          </a:xfrm>
-          <a:prstGeom prst="rect">
-            <a:avLst/>
-          </a:prstGeom>
-          <a:noFill/>
-        </p:spPr>
-        <p:txBody>
-          <a:bodyPr wrap="none">
-            <a:spAutoFit/>
-          </a:bodyPr>
-          <a:lstStyle/>
-          <a:p>
-            <a:pPr>
-              <a:defRPr sz="1200">
-                <a:solidFill>
-                  <a:srgbClr val="757575"/>
-                </a:solidFill>
-                <a:latin typeface="Hiragino Sans"/>
-              </a:defRPr>
-            </a:pPr>
-            <a:r>
-              <a:t>銀行業界の基礎知識 - 易化版</a:t>
-            </a:r>
-          </a:p>
-        </p:txBody>
-      </p:sp>
-      <p:sp>
-        <p:nvSpPr>
-          <p:cNvPr id="5" name="TextBox 4"/>
-          <p:cNvSpPr txBox="1"/>
-          <p:nvPr/>
-        </p:nvSpPr>
-        <p:spPr>
-          <a:xfrm>
-            <a:off x="457200" y="548640"/>
-            <a:ext cx="10972800" cy="914400"/>
-          </a:xfrm>
-          <a:prstGeom prst="rect">
-            <a:avLst/>
-          </a:prstGeom>
-          <a:noFill/>
-        </p:spPr>
-        <p:txBody>
-          <a:bodyPr wrap="none">
-            <a:spAutoFit/>
-          </a:bodyPr>
-          <a:lstStyle/>
-          <a:p>
-            <a:pPr>
-              <a:defRPr sz="2400">
-                <a:solidFill>
-                  <a:srgbClr val="757575"/>
-                </a:solidFill>
-                <a:latin typeface="Hiragino Sans"/>
-              </a:defRPr>
-            </a:pPr>
-            <a:r>
-              <a:t>私たちへの問いかけ</a:t>
-            </a:r>
-          </a:p>
-        </p:txBody>
-      </p:sp>
-      <p:sp>
-        <p:nvSpPr>
-          <p:cNvPr id="6" name="TextBox 5"/>
-          <p:cNvSpPr txBox="1"/>
-          <p:nvPr/>
-        </p:nvSpPr>
-        <p:spPr>
-          <a:xfrm>
-            <a:off x="457200" y="1371600"/>
-            <a:ext cx="11277295" cy="1097280"/>
-          </a:xfrm>
-          <a:prstGeom prst="rect">
-            <a:avLst/>
-          </a:prstGeom>
-          <a:noFill/>
-        </p:spPr>
-        <p:txBody>
-          <a:bodyPr wrap="square">
-            <a:spAutoFit/>
-          </a:bodyPr>
-          <a:lstStyle/>
-          <a:p>
-            <a:pPr>
-              <a:defRPr sz="3600" b="1">
-                <a:solidFill>
-                  <a:srgbClr val="1C1B19"/>
-                </a:solidFill>
-                <a:latin typeface="Hiragino Sans"/>
-              </a:defRPr>
-            </a:pPr>
-            <a:r>
-              <a:t>最後にお考えください。</a:t>
-            </a:r>
-          </a:p>
-        </p:txBody>
-      </p:sp>
-      <p:sp>
-        <p:nvSpPr>
-          <p:cNvPr id="7" name="TextBox 6"/>
-          <p:cNvSpPr txBox="1"/>
-          <p:nvPr/>
-        </p:nvSpPr>
-        <p:spPr>
-          <a:xfrm>
-            <a:off x="457200" y="2743200"/>
-            <a:ext cx="11277295" cy="3474720"/>
-          </a:xfrm>
-          <a:prstGeom prst="rect">
-            <a:avLst/>
-          </a:prstGeom>
-          <a:noFill/>
-        </p:spPr>
-        <p:txBody>
-          <a:bodyPr wrap="square" anchor="t">
-            <a:spAutoFit/>
-          </a:bodyPr>
-          <a:lstStyle/>
-          <a:p/>
-          <a:p>
-            <a:pPr>
-              <a:spcAft>
-                <a:spcPts val="2400"/>
-              </a:spcAft>
-              <a:defRPr sz="2600">
-                <a:solidFill>
-                  <a:srgbClr val="1C1B19"/>
-                </a:solidFill>
-                <a:latin typeface="Hiragino Sans"/>
-              </a:defRPr>
-            </a:pPr>
-            <a:r>
-              <a:t>● 「あなたが一番よく使うお金のアプリ（サービス）は何ですか？」</a:t>
-            </a:r>
-          </a:p>
-          <a:p>
-            <a:pPr>
-              <a:spcAft>
-                <a:spcPts val="2400"/>
-              </a:spcAft>
-              <a:defRPr sz="2600">
-                <a:solidFill>
-                  <a:srgbClr val="1C1B19"/>
-                </a:solidFill>
-                <a:latin typeface="Hiragino Sans"/>
-              </a:defRPr>
-            </a:pPr>
-            <a:r>
-              <a:t>● 「その理由は何ですか？（早い、安い、ポイントがつく…）」</a:t>
-            </a:r>
-          </a:p>
-          <a:p>
-            <a:pPr>
-              <a:spcAft>
-                <a:spcPts val="2400"/>
-              </a:spcAft>
-              <a:defRPr sz="2600">
-                <a:solidFill>
-                  <a:srgbClr val="1C1B19"/>
-                </a:solidFill>
-                <a:latin typeface="Hiragino Sans"/>
-              </a:defRPr>
-            </a:pPr>
-            <a:r>
-              <a:t>● それを考えることが、これからの金融の未来を知る第一歩です。</a:t>
             </a:r>
           </a:p>
         </p:txBody>
@@ -9447,8 +8576,8 @@
         </p:nvSpPr>
         <p:spPr>
           <a:xfrm>
-            <a:off x="457200" y="6492240"/>
-            <a:ext cx="4572000" cy="274320"/>
+            <a:off x="457200" y="548640"/>
+            <a:ext cx="10972800" cy="914400"/>
           </a:xfrm>
           <a:prstGeom prst="rect">
             <a:avLst/>
@@ -9462,7 +8591,7 @@
           <a:lstStyle/>
           <a:p>
             <a:pPr>
-              <a:defRPr sz="1200">
+              <a:defRPr sz="2400">
                 <a:solidFill>
                   <a:srgbClr val="757575"/>
                 </a:solidFill>
@@ -9470,7 +8599,7 @@
               </a:defRPr>
             </a:pPr>
             <a:r>
-              <a:t>銀行業界の基礎知識 - 易化版</a:t>
+              <a:t>本日のアジェンダ</a:t>
             </a:r>
           </a:p>
         </p:txBody>
@@ -9478,42 +8607,6 @@
       <p:sp>
         <p:nvSpPr>
           <p:cNvPr id="5" name="TextBox 4"/>
-          <p:cNvSpPr txBox="1"/>
-          <p:nvPr/>
-        </p:nvSpPr>
-        <p:spPr>
-          <a:xfrm>
-            <a:off x="457200" y="548640"/>
-            <a:ext cx="10972800" cy="914400"/>
-          </a:xfrm>
-          <a:prstGeom prst="rect">
-            <a:avLst/>
-          </a:prstGeom>
-          <a:noFill/>
-        </p:spPr>
-        <p:txBody>
-          <a:bodyPr wrap="none">
-            <a:spAutoFit/>
-          </a:bodyPr>
-          <a:lstStyle/>
-          <a:p>
-            <a:pPr>
-              <a:defRPr sz="2400">
-                <a:solidFill>
-                  <a:srgbClr val="757575"/>
-                </a:solidFill>
-                <a:latin typeface="Hiragino Sans"/>
-              </a:defRPr>
-            </a:pPr>
-            <a:r>
-              <a:t>本日のアジェンダ</a:t>
-            </a:r>
-          </a:p>
-        </p:txBody>
-      </p:sp>
-      <p:sp>
-        <p:nvSpPr>
-          <p:cNvPr id="6" name="TextBox 5"/>
           <p:cNvSpPr txBox="1"/>
           <p:nvPr/>
         </p:nvSpPr>
@@ -9549,14 +8642,14 @@
       </p:sp>
       <p:sp>
         <p:nvSpPr>
-          <p:cNvPr id="7" name="TextBox 6"/>
+          <p:cNvPr id="6" name="TextBox 5"/>
           <p:cNvSpPr txBox="1"/>
           <p:nvPr/>
         </p:nvSpPr>
         <p:spPr>
           <a:xfrm>
-            <a:off x="457200" y="2743200"/>
-            <a:ext cx="11277295" cy="3474720"/>
+            <a:off x="365760" y="2743200"/>
+            <a:ext cx="11430000" cy="3474720"/>
           </a:xfrm>
           <a:prstGeom prst="rect">
             <a:avLst/>
@@ -9927,8 +9020,8 @@
         </p:nvSpPr>
         <p:spPr>
           <a:xfrm>
-            <a:off x="457200" y="6492240"/>
-            <a:ext cx="4572000" cy="274320"/>
+            <a:off x="457200" y="548640"/>
+            <a:ext cx="10972800" cy="914400"/>
           </a:xfrm>
           <a:prstGeom prst="rect">
             <a:avLst/>
@@ -9942,7 +9035,7 @@
           <a:lstStyle/>
           <a:p>
             <a:pPr>
-              <a:defRPr sz="1200">
+              <a:defRPr sz="2400">
                 <a:solidFill>
                   <a:srgbClr val="757575"/>
                 </a:solidFill>
@@ -9950,7 +9043,7 @@
               </a:defRPr>
             </a:pPr>
             <a:r>
-              <a:t>銀行業界の基礎知識 - 易化版</a:t>
+              <a:t>銀行の歴史</a:t>
             </a:r>
           </a:p>
         </p:txBody>
@@ -9958,42 +9051,6 @@
       <p:sp>
         <p:nvSpPr>
           <p:cNvPr id="5" name="TextBox 4"/>
-          <p:cNvSpPr txBox="1"/>
-          <p:nvPr/>
-        </p:nvSpPr>
-        <p:spPr>
-          <a:xfrm>
-            <a:off x="457200" y="548640"/>
-            <a:ext cx="10972800" cy="914400"/>
-          </a:xfrm>
-          <a:prstGeom prst="rect">
-            <a:avLst/>
-          </a:prstGeom>
-          <a:noFill/>
-        </p:spPr>
-        <p:txBody>
-          <a:bodyPr wrap="none">
-            <a:spAutoFit/>
-          </a:bodyPr>
-          <a:lstStyle/>
-          <a:p>
-            <a:pPr>
-              <a:defRPr sz="2400">
-                <a:solidFill>
-                  <a:srgbClr val="757575"/>
-                </a:solidFill>
-                <a:latin typeface="Hiragino Sans"/>
-              </a:defRPr>
-            </a:pPr>
-            <a:r>
-              <a:t>銀行の歴史</a:t>
-            </a:r>
-          </a:p>
-        </p:txBody>
-      </p:sp>
-      <p:sp>
-        <p:nvSpPr>
-          <p:cNvPr id="6" name="TextBox 5"/>
           <p:cNvSpPr txBox="1"/>
           <p:nvPr/>
         </p:nvSpPr>
@@ -10029,7 +9086,7 @@
       </p:sp>
       <p:sp>
         <p:nvSpPr>
-          <p:cNvPr id="7" name="Rounded Rectangle 6"/>
+          <p:cNvPr id="6" name="Rounded Rectangle 5"/>
           <p:cNvSpPr/>
           <p:nvPr/>
         </p:nvSpPr>
@@ -10087,14 +9144,14 @@
       </p:sp>
       <p:sp>
         <p:nvSpPr>
-          <p:cNvPr id="8" name="Right Arrow 7"/>
+          <p:cNvPr id="7" name="Right Arrow 6"/>
           <p:cNvSpPr/>
           <p:nvPr/>
         </p:nvSpPr>
         <p:spPr>
           <a:xfrm>
-            <a:off x="5029200" y="3566160"/>
-            <a:ext cx="2103120" cy="640080"/>
+            <a:off x="5029200" y="3383280"/>
+            <a:ext cx="2103120" cy="1005840"/>
           </a:xfrm>
           <a:prstGeom prst="rightArrow">
             <a:avLst/>
@@ -10122,7 +9179,11 @@
           <a:lstStyle/>
           <a:p>
             <a:pPr algn="ctr">
-              <a:defRPr sz="1600"/>
+              <a:defRPr sz="1600">
+                <a:solidFill>
+                  <a:srgbClr val="FFFFFF"/>
+                </a:solidFill>
+              </a:defRPr>
             </a:pPr>
             <a:r>
               <a:t>お互いに合体！</a:t>
@@ -10136,7 +9197,7 @@
       </p:sp>
       <p:sp>
         <p:nvSpPr>
-          <p:cNvPr id="9" name="Rounded Rectangle 8"/>
+          <p:cNvPr id="8" name="Rounded Rectangle 7"/>
           <p:cNvSpPr/>
           <p:nvPr/>
         </p:nvSpPr>
@@ -10472,8 +9533,8 @@
         </p:nvSpPr>
         <p:spPr>
           <a:xfrm>
-            <a:off x="457200" y="6492240"/>
-            <a:ext cx="4572000" cy="274320"/>
+            <a:off x="457200" y="548640"/>
+            <a:ext cx="10972800" cy="914400"/>
           </a:xfrm>
           <a:prstGeom prst="rect">
             <a:avLst/>
@@ -10487,7 +9548,7 @@
           <a:lstStyle/>
           <a:p>
             <a:pPr>
-              <a:defRPr sz="1200">
+              <a:defRPr sz="2400">
                 <a:solidFill>
                   <a:srgbClr val="757575"/>
                 </a:solidFill>
@@ -10495,7 +9556,7 @@
               </a:defRPr>
             </a:pPr>
             <a:r>
-              <a:t>銀行業界の基礎知識 - 易化版</a:t>
+              <a:t>銀行の三大業務（大切なお仕事）</a:t>
             </a:r>
           </a:p>
         </p:txBody>
@@ -10503,42 +9564,6 @@
       <p:sp>
         <p:nvSpPr>
           <p:cNvPr id="5" name="TextBox 4"/>
-          <p:cNvSpPr txBox="1"/>
-          <p:nvPr/>
-        </p:nvSpPr>
-        <p:spPr>
-          <a:xfrm>
-            <a:off x="457200" y="548640"/>
-            <a:ext cx="10972800" cy="914400"/>
-          </a:xfrm>
-          <a:prstGeom prst="rect">
-            <a:avLst/>
-          </a:prstGeom>
-          <a:noFill/>
-        </p:spPr>
-        <p:txBody>
-          <a:bodyPr wrap="none">
-            <a:spAutoFit/>
-          </a:bodyPr>
-          <a:lstStyle/>
-          <a:p>
-            <a:pPr>
-              <a:defRPr sz="2400">
-                <a:solidFill>
-                  <a:srgbClr val="757575"/>
-                </a:solidFill>
-                <a:latin typeface="Hiragino Sans"/>
-              </a:defRPr>
-            </a:pPr>
-            <a:r>
-              <a:t>銀行の三大業務（大切なお仕事）</a:t>
-            </a:r>
-          </a:p>
-        </p:txBody>
-      </p:sp>
-      <p:sp>
-        <p:nvSpPr>
-          <p:cNvPr id="6" name="TextBox 5"/>
           <p:cNvSpPr txBox="1"/>
           <p:nvPr/>
         </p:nvSpPr>
@@ -10574,14 +9599,14 @@
       </p:sp>
       <p:sp>
         <p:nvSpPr>
-          <p:cNvPr id="7" name="TextBox 6"/>
+          <p:cNvPr id="6" name="TextBox 5"/>
           <p:cNvSpPr txBox="1"/>
           <p:nvPr/>
         </p:nvSpPr>
         <p:spPr>
           <a:xfrm>
-            <a:off x="457200" y="2743200"/>
-            <a:ext cx="11277295" cy="3474720"/>
+            <a:off x="365760" y="2743200"/>
+            <a:ext cx="11430000" cy="3474720"/>
           </a:xfrm>
           <a:prstGeom prst="rect">
             <a:avLst/>
@@ -10750,8 +9775,8 @@
         </p:nvSpPr>
         <p:spPr>
           <a:xfrm>
-            <a:off x="457200" y="6492240"/>
-            <a:ext cx="4572000" cy="274320"/>
+            <a:off x="457200" y="548640"/>
+            <a:ext cx="10972800" cy="914400"/>
           </a:xfrm>
           <a:prstGeom prst="rect">
             <a:avLst/>
@@ -10765,7 +9790,7 @@
           <a:lstStyle/>
           <a:p>
             <a:pPr>
-              <a:defRPr sz="1200">
+              <a:defRPr sz="2400">
                 <a:solidFill>
                   <a:srgbClr val="757575"/>
                 </a:solidFill>
@@ -10773,7 +9798,7 @@
               </a:defRPr>
             </a:pPr>
             <a:r>
-              <a:t>銀行業界の基礎知識 - 易化版</a:t>
+              <a:t>お金のめぐり方</a:t>
             </a:r>
           </a:p>
         </p:txBody>
@@ -10781,42 +9806,6 @@
       <p:sp>
         <p:nvSpPr>
           <p:cNvPr id="5" name="TextBox 4"/>
-          <p:cNvSpPr txBox="1"/>
-          <p:nvPr/>
-        </p:nvSpPr>
-        <p:spPr>
-          <a:xfrm>
-            <a:off x="457200" y="548640"/>
-            <a:ext cx="10972800" cy="914400"/>
-          </a:xfrm>
-          <a:prstGeom prst="rect">
-            <a:avLst/>
-          </a:prstGeom>
-          <a:noFill/>
-        </p:spPr>
-        <p:txBody>
-          <a:bodyPr wrap="none">
-            <a:spAutoFit/>
-          </a:bodyPr>
-          <a:lstStyle/>
-          <a:p>
-            <a:pPr>
-              <a:defRPr sz="2400">
-                <a:solidFill>
-                  <a:srgbClr val="757575"/>
-                </a:solidFill>
-                <a:latin typeface="Hiragino Sans"/>
-              </a:defRPr>
-            </a:pPr>
-            <a:r>
-              <a:t>お金のめぐり方</a:t>
-            </a:r>
-          </a:p>
-        </p:txBody>
-      </p:sp>
-      <p:sp>
-        <p:nvSpPr>
-          <p:cNvPr id="6" name="TextBox 5"/>
           <p:cNvSpPr txBox="1"/>
           <p:nvPr/>
         </p:nvSpPr>
@@ -10852,14 +9841,14 @@
       </p:sp>
       <p:sp>
         <p:nvSpPr>
-          <p:cNvPr id="7" name="TextBox 6"/>
+          <p:cNvPr id="6" name="TextBox 5"/>
           <p:cNvSpPr txBox="1"/>
           <p:nvPr/>
         </p:nvSpPr>
         <p:spPr>
           <a:xfrm>
-            <a:off x="457200" y="2743200"/>
-            <a:ext cx="11277295" cy="3474720"/>
+            <a:off x="365760" y="2743200"/>
+            <a:ext cx="11430000" cy="3474720"/>
           </a:xfrm>
           <a:prstGeom prst="rect">
             <a:avLst/>

</xml_diff>

<commit_message>
Fix trailing overflow by redesigning industry map box widths (n)
</commit_message>
<xml_diff>
--- a/bank-normal/bank_normal_presentation.pptx
+++ b/bank-normal/bank_normal_presentation.pptx
@@ -5263,8 +5263,8 @@
         </p:nvSpPr>
         <p:spPr>
           <a:xfrm>
-            <a:off x="914400" y="2743200"/>
-            <a:ext cx="2743200" cy="2286000"/>
+            <a:off x="548640" y="2743200"/>
+            <a:ext cx="2560320" cy="2286000"/>
           </a:xfrm>
           <a:prstGeom prst="roundRect">
             <a:avLst/>
@@ -5292,7 +5292,7 @@
           <a:lstStyle/>
           <a:p>
             <a:pPr algn="ctr">
-              <a:defRPr sz="2000" b="1">
+              <a:defRPr sz="1800" b="1">
                 <a:solidFill>
                   <a:srgbClr val="FFFFFF"/>
                 </a:solidFill>
@@ -5317,8 +5317,8 @@
         </p:nvSpPr>
         <p:spPr>
           <a:xfrm>
-            <a:off x="3840480" y="2743200"/>
-            <a:ext cx="2743200" cy="2286000"/>
+            <a:off x="3383280" y="2743200"/>
+            <a:ext cx="2560320" cy="2286000"/>
           </a:xfrm>
           <a:prstGeom prst="roundRect">
             <a:avLst/>
@@ -5351,7 +5351,7 @@
           <a:lstStyle/>
           <a:p>
             <a:pPr algn="ctr">
-              <a:defRPr sz="2000" b="1">
+              <a:defRPr sz="1800" b="1">
                 <a:solidFill>
                   <a:srgbClr val="1C1B19"/>
                 </a:solidFill>
@@ -5376,8 +5376,8 @@
         </p:nvSpPr>
         <p:spPr>
           <a:xfrm>
-            <a:off x="6766560" y="2743200"/>
-            <a:ext cx="2743200" cy="2286000"/>
+            <a:off x="6217920" y="2743200"/>
+            <a:ext cx="2560320" cy="2286000"/>
           </a:xfrm>
           <a:prstGeom prst="roundRect">
             <a:avLst/>
@@ -5410,7 +5410,7 @@
           <a:lstStyle/>
           <a:p>
             <a:pPr algn="ctr">
-              <a:defRPr sz="2000" b="1">
+              <a:defRPr sz="1800" b="1">
                 <a:solidFill>
                   <a:srgbClr val="1C1B19"/>
                 </a:solidFill>
@@ -5435,8 +5435,8 @@
         </p:nvSpPr>
         <p:spPr>
           <a:xfrm>
-            <a:off x="9692640" y="2743200"/>
-            <a:ext cx="2743200" cy="2286000"/>
+            <a:off x="9052560" y="2743200"/>
+            <a:ext cx="2560320" cy="2286000"/>
           </a:xfrm>
           <a:prstGeom prst="roundRect">
             <a:avLst/>
@@ -5469,7 +5469,7 @@
           <a:lstStyle/>
           <a:p>
             <a:pPr algn="ctr">
-              <a:defRPr sz="2000" b="1">
+              <a:defRPr sz="1800" b="1">
                 <a:solidFill>
                   <a:srgbClr val="1C1B19"/>
                 </a:solidFill>

</xml_diff>

<commit_message>
Fix CHAPTER numbering mismatch to align with Agenda (n)
</commit_message>
<xml_diff>
--- a/bank-normal/bank_normal_presentation.pptx
+++ b/bank-normal/bank_normal_presentation.pptx
@@ -5044,7 +5044,7 @@
               </a:defRPr>
             </a:pPr>
             <a:r>
-              <a:t>CHAPTER 4</a:t>
+              <a:t>CHAPTER 3</a:t>
             </a:r>
           </a:p>
         </p:txBody>
@@ -6067,7 +6067,7 @@
               </a:defRPr>
             </a:pPr>
             <a:r>
-              <a:t>CHAPTER 5</a:t>
+              <a:t>CHAPTER 4</a:t>
             </a:r>
           </a:p>
         </p:txBody>
@@ -7189,7 +7189,7 @@
               </a:defRPr>
             </a:pPr>
             <a:r>
-              <a:t>CHAPTER 6</a:t>
+              <a:t>CHAPTER 5</a:t>
             </a:r>
           </a:p>
         </p:txBody>
@@ -8036,9 +8036,6 @@
                 <a:latin typeface="Hiragino Sans"/>
               </a:defRPr>
             </a:pPr>
-            <a:r>
-              <a:t>CHAPTER 7</a:t>
-            </a:r>
           </a:p>
         </p:txBody>
       </p:sp>
@@ -8428,9 +8425,6 @@
                 <a:latin typeface="Hiragino Sans"/>
               </a:defRPr>
             </a:pPr>
-            <a:r>
-              <a:t>CHAPTER 1</a:t>
-            </a:r>
           </a:p>
         </p:txBody>
       </p:sp>
@@ -8873,7 +8867,7 @@
               </a:defRPr>
             </a:pPr>
             <a:r>
-              <a:t>CHAPTER 2</a:t>
+              <a:t>CHAPTER 1</a:t>
             </a:r>
           </a:p>
         </p:txBody>
@@ -9386,7 +9380,7 @@
               </a:defRPr>
             </a:pPr>
             <a:r>
-              <a:t>CHAPTER 3</a:t>
+              <a:t>CHAPTER 2</a:t>
             </a:r>
           </a:p>
         </p:txBody>

</xml_diff>